<commit_message>
Update Day 1 and Day 2 notebooks and lecture slides
</commit_message>
<xml_diff>
--- a/lecture_slides/4.day2_after_lunch/lecture_4b_from_research_question_to_fine-tuned_model.pptx
+++ b/lecture_slides/4.day2_after_lunch/lecture_4b_from_research_question_to_fine-tuned_model.pptx
@@ -13387,7 +13387,7 @@
           <a:p>
             <a:fld id="{30E08F2E-5F06-4CE2-A139-452A1382A6F0}" type="datetimeFigureOut">
               <a:rPr lang="en-US"/>
-              <a:t>2/14/26</a:t>
+              <a:t>2/16/26</a:t>
             </a:fld>
             <a:endParaRPr/>
           </a:p>
@@ -13552,7 +13552,7 @@
           <a:p>
             <a:fld id="{1A4C5DC6-1594-414D-9341-ABA08739246C}" type="datetimeFigureOut">
               <a:rPr lang="en-US"/>
-              <a:t>2/14/26</a:t>
+              <a:t>2/16/26</a:t>
             </a:fld>
             <a:endParaRPr/>
           </a:p>
@@ -19834,13 +19834,6 @@
             <a:pPr lvl="1"/>
             <a:r>
               <a:rPr lang="en-US" sz="2200" dirty="0"/>
-              <a:t>Chromosome splits only → can still share repeats/homology</a:t>
-            </a:r>
-          </a:p>
-          <a:p>
-            <a:pPr lvl="1"/>
-            <a:r>
-              <a:rPr lang="en-US" sz="2200" dirty="0"/>
               <a:t>Mixing species / cell types without modeling domain shift</a:t>
             </a:r>
           </a:p>
@@ -20590,7 +20583,7 @@
           <a:p>
             <a:r>
               <a:rPr lang="en-US" dirty="0"/>
-              <a:t>Genomic Foundation Model use may fail due to misjudgments at different phases</a:t>
+              <a:t>Genomic Foundation Model usage may fail due to misjudgments at different phases</a:t>
             </a:r>
           </a:p>
           <a:p>
@@ -21342,7 +21335,7 @@
           <a:p>
             <a:r>
               <a:rPr lang="en-US" dirty="0"/>
-              <a:t>Learning Objectives</a:t>
+              <a:t>Suggested Workflow </a:t>
             </a:r>
             <a:endParaRPr lang="en-SA" dirty="0"/>
           </a:p>
@@ -21405,7 +21398,7 @@
 </file>
 
 <file path=ppt/slides/slide4.xml><?xml version="1.0" encoding="utf-8"?>
-<p:sld xmlns:a="http://schemas.openxmlformats.org/drawingml/2006/main" xmlns:r="http://schemas.openxmlformats.org/officeDocument/2006/relationships" xmlns:p="http://schemas.openxmlformats.org/presentationml/2006/main">
+<p:sld xmlns:a="http://schemas.openxmlformats.org/drawingml/2006/main" xmlns:r="http://schemas.openxmlformats.org/officeDocument/2006/relationships" xmlns:p="http://schemas.openxmlformats.org/presentationml/2006/main" show="0">
   <p:cSld>
     <p:spTree>
       <p:nvGrpSpPr>
@@ -21491,13 +21484,13 @@
   <p:clrMapOvr>
     <a:masterClrMapping/>
   </p:clrMapOvr>
-  <mc:AlternateContent xmlns:mc="http://schemas.openxmlformats.org/markup-compatibility/2006" xmlns:p14="http://schemas.microsoft.com/office/powerpoint/2010/main">
-    <mc:Choice Requires="p14">
+  <mc:AlternateContent xmlns:mc="http://schemas.openxmlformats.org/markup-compatibility/2006">
+    <mc:Choice xmlns:p14="http://schemas.microsoft.com/office/powerpoint/2010/main" Requires="p14">
       <p:transition spd="med" p14:dur="700">
         <p:fade/>
       </p:transition>
     </mc:Choice>
-    <mc:Fallback xmlns="">
+    <mc:Fallback>
       <p:transition spd="med">
         <p:fade/>
       </p:transition>
@@ -21567,7 +21560,12 @@
             <p:ph idx="1"/>
           </p:nvPr>
         </p:nvSpPr>
-        <p:spPr/>
+        <p:spPr>
+          <a:xfrm>
+            <a:off x="1410027" y="1566001"/>
+            <a:ext cx="4451930" cy="4620682"/>
+          </a:xfrm>
+        </p:spPr>
         <p:txBody>
           <a:bodyPr>
             <a:normAutofit/>
@@ -21607,16 +21605,40 @@
             </a:r>
           </a:p>
           <a:p>
-            <a:r>
-              <a:rPr lang="en-US" dirty="0"/>
-              <a:t>Resolution: Locus-level, human genome, single cell type (K562)</a:t>
-            </a:r>
-          </a:p>
-          <a:p>
             <a:endParaRPr lang="en-US" dirty="0"/>
           </a:p>
         </p:txBody>
       </p:sp>
+      <p:pic>
+        <p:nvPicPr>
+          <p:cNvPr id="4" name="Picture 3">
+            <a:extLst>
+              <a:ext uri="{FF2B5EF4-FFF2-40B4-BE49-F238E27FC236}">
+                <a16:creationId xmlns:a16="http://schemas.microsoft.com/office/drawing/2014/main" id="{5C84CCC9-AF1B-2C84-55BC-82948E398030}"/>
+              </a:ext>
+            </a:extLst>
+          </p:cNvPr>
+          <p:cNvPicPr>
+            <a:picLocks noChangeAspect="1"/>
+          </p:cNvPicPr>
+          <p:nvPr/>
+        </p:nvPicPr>
+        <p:blipFill>
+          <a:blip r:embed="rId2"/>
+          <a:stretch>
+            <a:fillRect/>
+          </a:stretch>
+        </p:blipFill>
+        <p:spPr>
+          <a:xfrm>
+            <a:off x="5861957" y="1836208"/>
+            <a:ext cx="6192555" cy="3455791"/>
+          </a:xfrm>
+          <a:prstGeom prst="rect">
+            <a:avLst/>
+          </a:prstGeom>
+        </p:spPr>
+      </p:pic>
     </p:spTree>
     <p:extLst>
       <p:ext uri="{BB962C8B-B14F-4D97-AF65-F5344CB8AC3E}">
@@ -21712,7 +21734,7 @@
         </p:spPr>
         <p:txBody>
           <a:bodyPr>
-            <a:normAutofit lnSpcReduction="10000"/>
+            <a:normAutofit fontScale="92500" lnSpcReduction="10000"/>
           </a:bodyPr>
           <a:lstStyle/>
           <a:p>
@@ -21783,7 +21805,14 @@
             <a:pPr lvl="1"/>
             <a:r>
               <a:rPr lang="en-US" sz="2200" dirty="0"/>
-              <a:t>Locus-level, genome-wide, single-cell, cross-species?</a:t>
+              <a:t>Locus-level (DNA window, e.g., 500bp/ 1kb, around candidate enhancers)</a:t>
+            </a:r>
+          </a:p>
+          <a:p>
+            <a:pPr lvl="1"/>
+            <a:r>
+              <a:rPr lang="en-US" sz="2200" dirty="0"/>
+              <a:t>Genome-wide (scan the genome in sliding windows)</a:t>
             </a:r>
           </a:p>
           <a:p>
@@ -24239,12 +24268,23 @@
 </file>
 
 <file path=customXml/item1.xml><?xml version="1.0" encoding="utf-8"?>
-<?mso-contentType ?>
-<FormTemplates xmlns="http://schemas.microsoft.com/sharepoint/v3/contenttype/forms">
-  <Display>DocumentLibraryForm</Display>
-  <Edit>DocumentLibraryForm</Edit>
-  <New>DocumentLibraryForm</New>
-</FormTemplates>
+<p:properties xmlns:p="http://schemas.microsoft.com/office/2006/metadata/properties" xmlns:xsi="http://www.w3.org/2001/XMLSchema-instance" xmlns:pc="http://schemas.microsoft.com/office/infopath/2007/PartnerControls">
+  <documentManagement>
+    <_ip_UnifiedCompliancePolicyUIAction xmlns="http://schemas.microsoft.com/sharepoint/v3" xsi:nil="true"/>
+    <Image xmlns="71af3243-3dd4-4a8d-8c0d-dd76da1f02a5">
+      <Url xsi:nil="true"/>
+      <Description xsi:nil="true"/>
+    </Image>
+    <Status xmlns="71af3243-3dd4-4a8d-8c0d-dd76da1f02a5">Not started</Status>
+    <Background xmlns="71af3243-3dd4-4a8d-8c0d-dd76da1f02a5">false</Background>
+    <_ip_UnifiedCompliancePolicyProperties xmlns="http://schemas.microsoft.com/sharepoint/v3" xsi:nil="true"/>
+    <ImageTagsTaxHTField xmlns="71af3243-3dd4-4a8d-8c0d-dd76da1f02a5">
+      <Terms xmlns="http://schemas.microsoft.com/office/infopath/2007/PartnerControls"/>
+    </ImageTagsTaxHTField>
+    <TaxCatchAll xmlns="230e9df3-be65-4c73-a93b-d1236ebd677e" xsi:nil="true"/>
+    <MediaServiceKeyPoints xmlns="71af3243-3dd4-4a8d-8c0d-dd76da1f02a5" xsi:nil="true"/>
+  </documentManagement>
+</p:properties>
 </file>
 
 <file path=customXml/item2.xml><?xml version="1.0" encoding="utf-8"?>
@@ -24554,29 +24594,29 @@
 </file>
 
 <file path=customXml/item3.xml><?xml version="1.0" encoding="utf-8"?>
-<p:properties xmlns:p="http://schemas.microsoft.com/office/2006/metadata/properties" xmlns:xsi="http://www.w3.org/2001/XMLSchema-instance" xmlns:pc="http://schemas.microsoft.com/office/infopath/2007/PartnerControls">
-  <documentManagement>
-    <_ip_UnifiedCompliancePolicyUIAction xmlns="http://schemas.microsoft.com/sharepoint/v3" xsi:nil="true"/>
-    <Image xmlns="71af3243-3dd4-4a8d-8c0d-dd76da1f02a5">
-      <Url xsi:nil="true"/>
-      <Description xsi:nil="true"/>
-    </Image>
-    <Status xmlns="71af3243-3dd4-4a8d-8c0d-dd76da1f02a5">Not started</Status>
-    <Background xmlns="71af3243-3dd4-4a8d-8c0d-dd76da1f02a5">false</Background>
-    <_ip_UnifiedCompliancePolicyProperties xmlns="http://schemas.microsoft.com/sharepoint/v3" xsi:nil="true"/>
-    <ImageTagsTaxHTField xmlns="71af3243-3dd4-4a8d-8c0d-dd76da1f02a5">
-      <Terms xmlns="http://schemas.microsoft.com/office/infopath/2007/PartnerControls"/>
-    </ImageTagsTaxHTField>
-    <TaxCatchAll xmlns="230e9df3-be65-4c73-a93b-d1236ebd677e" xsi:nil="true"/>
-    <MediaServiceKeyPoints xmlns="71af3243-3dd4-4a8d-8c0d-dd76da1f02a5" xsi:nil="true"/>
-  </documentManagement>
-</p:properties>
+<?mso-contentType ?>
+<FormTemplates xmlns="http://schemas.microsoft.com/sharepoint/v3/contenttype/forms">
+  <Display>DocumentLibraryForm</Display>
+  <Edit>DocumentLibraryForm</Edit>
+  <New>DocumentLibraryForm</New>
+</FormTemplates>
 </file>
 
 <file path=customXml/itemProps1.xml><?xml version="1.0" encoding="utf-8"?>
-<ds:datastoreItem xmlns:ds="http://schemas.openxmlformats.org/officeDocument/2006/customXml" ds:itemID="{78F2847D-96C7-4634-93AB-D232DDB6E5EB}">
+<ds:datastoreItem xmlns:ds="http://schemas.openxmlformats.org/officeDocument/2006/customXml" ds:itemID="{4D18307F-863E-465D-9426-B14DA0CBD25E}">
   <ds:schemaRefs>
-    <ds:schemaRef ds:uri="http://schemas.microsoft.com/sharepoint/v3/contenttype/forms"/>
+    <ds:schemaRef ds:uri="http://schemas.microsoft.com/sharepoint/v3"/>
+    <ds:schemaRef ds:uri="16c05727-aa75-4e4a-9b5f-8a80a1165891"/>
+    <ds:schemaRef ds:uri="http://schemas.microsoft.com/office/2006/metadata/properties"/>
+    <ds:schemaRef ds:uri="http://www.w3.org/XML/1998/namespace"/>
+    <ds:schemaRef ds:uri="230e9df3-be65-4c73-a93b-d1236ebd677e"/>
+    <ds:schemaRef ds:uri="http://purl.org/dc/terms/"/>
+    <ds:schemaRef ds:uri="http://schemas.microsoft.com/office/infopath/2007/PartnerControls"/>
+    <ds:schemaRef ds:uri="http://schemas.microsoft.com/office/2006/documentManagement/types"/>
+    <ds:schemaRef ds:uri="http://purl.org/dc/elements/1.1/"/>
+    <ds:schemaRef ds:uri="http://schemas.openxmlformats.org/package/2006/metadata/core-properties"/>
+    <ds:schemaRef ds:uri="71af3243-3dd4-4a8d-8c0d-dd76da1f02a5"/>
+    <ds:schemaRef ds:uri="http://purl.org/dc/dcmitype/"/>
   </ds:schemaRefs>
 </ds:datastoreItem>
 </file>
@@ -24603,20 +24643,9 @@
 </file>
 
 <file path=customXml/itemProps3.xml><?xml version="1.0" encoding="utf-8"?>
-<ds:datastoreItem xmlns:ds="http://schemas.openxmlformats.org/officeDocument/2006/customXml" ds:itemID="{4D18307F-863E-465D-9426-B14DA0CBD25E}">
+<ds:datastoreItem xmlns:ds="http://schemas.openxmlformats.org/officeDocument/2006/customXml" ds:itemID="{78F2847D-96C7-4634-93AB-D232DDB6E5EB}">
   <ds:schemaRefs>
-    <ds:schemaRef ds:uri="http://schemas.microsoft.com/sharepoint/v3"/>
-    <ds:schemaRef ds:uri="16c05727-aa75-4e4a-9b5f-8a80a1165891"/>
-    <ds:schemaRef ds:uri="http://schemas.microsoft.com/office/2006/metadata/properties"/>
-    <ds:schemaRef ds:uri="http://www.w3.org/XML/1998/namespace"/>
-    <ds:schemaRef ds:uri="230e9df3-be65-4c73-a93b-d1236ebd677e"/>
-    <ds:schemaRef ds:uri="http://purl.org/dc/terms/"/>
-    <ds:schemaRef ds:uri="http://schemas.microsoft.com/office/infopath/2007/PartnerControls"/>
-    <ds:schemaRef ds:uri="http://schemas.microsoft.com/office/2006/documentManagement/types"/>
-    <ds:schemaRef ds:uri="http://purl.org/dc/elements/1.1/"/>
-    <ds:schemaRef ds:uri="http://schemas.openxmlformats.org/package/2006/metadata/core-properties"/>
-    <ds:schemaRef ds:uri="71af3243-3dd4-4a8d-8c0d-dd76da1f02a5"/>
-    <ds:schemaRef ds:uri="http://purl.org/dc/dcmitype/"/>
+    <ds:schemaRef ds:uri="http://schemas.microsoft.com/sharepoint/v3/contenttype/forms"/>
   </ds:schemaRefs>
 </ds:datastoreItem>
 </file>

</xml_diff>